<commit_message>
Clarify Compose image version tags
</commit_message>
<xml_diff>
--- a/slides/docker-session6-fullstack-todo.pptx
+++ b/slides/docker-session6-fullstack-todo.pptx
@@ -17,6 +17,7 @@
     <p:sldId xmlns:r="http://schemas.openxmlformats.org/officeDocument/2006/relationships" id="262" r:id="R505afd6e76824828"/>
     <p:sldId xmlns:r="http://schemas.openxmlformats.org/officeDocument/2006/relationships" id="263" r:id="R62a01bea38a748e6"/>
     <p:sldId xmlns:r="http://schemas.openxmlformats.org/officeDocument/2006/relationships" id="264" r:id="Rd1c1787bf3854863"/>
+    <p:sldId xmlns:r="http://schemas.openxmlformats.org/officeDocument/2006/relationships" id="272" r:id="rIdCodexComposeTag17"/>
     <p:sldId xmlns:r="http://schemas.openxmlformats.org/officeDocument/2006/relationships" id="265" r:id="R5781590e9e464878"/>
     <p:sldId xmlns:r="http://schemas.openxmlformats.org/officeDocument/2006/relationships" id="266" r:id="R3b172b3833934dae"/>
     <p:sldId xmlns:r="http://schemas.openxmlformats.org/officeDocument/2006/relationships" id="267" r:id="Ra67c9973821e479c"/>
@@ -8355,6 +8356,803 @@
 </p:sld>
 </file>
 
+<file path=ppt/slides/slide17.xml><?xml version="1.0" encoding="utf-8"?>
+<p:sld xmlns:a="http://schemas.openxmlformats.org/drawingml/2006/main" xmlns:p="http://schemas.openxmlformats.org/presentationml/2006/main" xmlns:r="http://schemas.openxmlformats.org/officeDocument/2006/relationships">
+  <p:cSld name="Compose 版本標籤">
+    <p:bg>
+      <p:bgPr>
+        <a:solidFill>
+          <a:srgbClr val="F6F8FB"/>
+        </a:solidFill>
+      </p:bgPr>
+    </p:bg>
+    <p:spTree>
+      <p:nvGrpSpPr>
+        <p:cNvPr id="1" name=""/>
+        <p:cNvGrpSpPr/>
+        <p:nvPr/>
+      </p:nvGrpSpPr>
+      <p:grpSpPr>
+        <a:xfrm/>
+      </p:grpSpPr>
+      <p:sp>
+        <p:nvSpPr>
+          <p:cNvPr id="2" name=""/>
+          <p:cNvSpPr>
+            <a:spLocks noGrp="1"/>
+          </p:cNvSpPr>
+          <p:nvPr/>
+        </p:nvSpPr>
+        <p:spPr>
+          <a:xfrm>
+            <a:off x="685800" y="400050"/>
+            <a:ext cx="6191250" cy="228600"/>
+          </a:xfrm>
+          <a:prstGeom prst="rect">
+            <a:avLst/>
+          </a:prstGeom>
+          <a:noFill/>
+          <a:ln w="0">
+            <a:noFill/>
+            <a:prstDash val="solid"/>
+          </a:ln>
+        </p:spPr>
+        <p:txBody>
+          <a:bodyPr lIns="0" tIns="0" rIns="0" bIns="0" anchor="t">
+            <a:normAutofit fontScale="100000"/>
+          </a:bodyPr>
+          <a:lstStyle/>
+          <a:p>
+            <a:pPr algn="l">
+              <a:lnSpc>
+                <a:spcPct val="106000"/>
+              </a:lnSpc>
+              <a:buNone/>
+              <a:defRPr sz="900" b="1">
+                <a:solidFill>
+                  <a:srgbClr val="0B5CAD"/>
+                </a:solidFill>
+                <a:latin typeface="Aptos"/>
+                <a:ea typeface="Aptos"/>
+                <a:cs typeface="Aptos"/>
+              </a:defRPr>
+            </a:pPr>
+            <a:r>
+              <a:rPr sz="900" b="1">
+                <a:solidFill>
+                  <a:srgbClr val="0B5CAD"/>
+                </a:solidFill>
+                <a:latin typeface="Aptos"/>
+                <a:ea typeface="Aptos"/>
+                <a:cs typeface="Aptos"/>
+              </a:rPr>
+              <a:t>COMPOSE TAGGING</a:t>
+            </a:r>
+          </a:p>
+        </p:txBody>
+      </p:sp>
+      <p:sp>
+        <p:nvSpPr>
+          <p:cNvPr id="3" name=""/>
+          <p:cNvSpPr>
+            <a:spLocks noGrp="1"/>
+          </p:cNvSpPr>
+          <p:nvPr/>
+        </p:nvSpPr>
+        <p:spPr>
+          <a:xfrm>
+            <a:off x="685800" y="742950"/>
+            <a:ext cx="9906000" cy="571500"/>
+          </a:xfrm>
+          <a:prstGeom prst="rect">
+            <a:avLst/>
+          </a:prstGeom>
+          <a:noFill/>
+          <a:ln w="0">
+            <a:noFill/>
+            <a:prstDash val="solid"/>
+          </a:ln>
+        </p:spPr>
+        <p:txBody>
+          <a:bodyPr lIns="0" tIns="0" rIns="0" bIns="0" anchor="t">
+            <a:normAutofit fontScale="100000"/>
+          </a:bodyPr>
+          <a:lstStyle/>
+          <a:p>
+            <a:pPr algn="l">
+              <a:lnSpc>
+                <a:spcPct val="106000"/>
+              </a:lnSpc>
+              <a:buNone/>
+              <a:defRPr sz="2750" b="1">
+                <a:solidFill>
+                  <a:srgbClr val="0B1220"/>
+                </a:solidFill>
+                <a:latin typeface="Aptos Display"/>
+                <a:ea typeface="Aptos Display"/>
+                <a:cs typeface="Aptos Display"/>
+              </a:defRPr>
+            </a:pPr>
+            <a:r>
+              <a:rPr sz="2750" b="1">
+                <a:solidFill>
+                  <a:srgbClr val="0B1220"/>
+                </a:solidFill>
+                <a:latin typeface="Aptos Display"/>
+                <a:ea typeface="Aptos Display"/>
+                <a:cs typeface="Aptos Display"/>
+              </a:rPr>
+              <a:t>Compose 裡版本號該寫在哪裡？</a:t>
+            </a:r>
+          </a:p>
+        </p:txBody>
+      </p:sp>
+      <p:sp>
+        <p:nvSpPr>
+          <p:cNvPr id="4" name=""/>
+          <p:cNvSpPr>
+            <a:spLocks noGrp="1"/>
+          </p:cNvSpPr>
+          <p:nvPr/>
+        </p:nvSpPr>
+        <p:spPr>
+          <a:xfrm>
+            <a:off x="685800" y="1457325"/>
+            <a:ext cx="3238500" cy="2476500"/>
+          </a:xfrm>
+          <a:prstGeom prst="roundRect">
+            <a:avLst>
+              <a:gd name="adj" fmla="val 8000"/>
+            </a:avLst>
+          </a:prstGeom>
+          <a:solidFill>
+            <a:srgbClr val="E8F3FF"/>
+          </a:solidFill>
+          <a:ln w="9525">
+            <a:solidFill>
+              <a:srgbClr val="B7DCFF"/>
+            </a:solidFill>
+            <a:prstDash val="solid"/>
+          </a:ln>
+        </p:spPr>
+        <p:txBody>
+          <a:bodyPr lIns="209550" tIns="209550" rIns="209550" bIns="209550" anchor="t">
+            <a:normAutofit fontScale="100000"/>
+          </a:bodyPr>
+          <a:lstStyle/>
+          <a:p>
+            <a:pPr algn="ctr">
+              <a:lnSpc>
+                <a:spcPct val="106000"/>
+              </a:lnSpc>
+              <a:buNone/>
+              <a:defRPr sz="1700" b="1">
+                <a:solidFill>
+                  <a:srgbClr val="0B5CAD"/>
+                </a:solidFill>
+                <a:latin typeface="Aptos Display"/>
+                <a:ea typeface="Aptos Display"/>
+                <a:cs typeface="Aptos Display"/>
+              </a:defRPr>
+            </a:pPr>
+            <a:r>
+              <a:rPr sz="1700" b="1">
+                <a:solidFill>
+                  <a:srgbClr val="0B5CAD"/>
+                </a:solidFill>
+                <a:latin typeface="Aptos Display"/>
+                <a:ea typeface="Aptos Display"/>
+                <a:cs typeface="Aptos Display"/>
+              </a:rPr>
+              <a:t>Compose 檔案</a:t>
+            </a:r>
+          </a:p>
+          <a:p>
+            <a:pPr>
+              <a:buNone/>
+              <a:defRPr sz="500"/>
+            </a:pPr>
+          </a:p>
+          <a:p>
+            <a:pPr algn="ctr">
+              <a:lnSpc>
+                <a:spcPct val="106000"/>
+              </a:lnSpc>
+              <a:buNone/>
+              <a:defRPr sz="1225" b="1">
+                <a:solidFill>
+                  <a:srgbClr val="0B1220"/>
+                </a:solidFill>
+                <a:latin typeface="Aptos"/>
+                <a:ea typeface="Aptos"/>
+                <a:cs typeface="Aptos"/>
+              </a:defRPr>
+            </a:pPr>
+            <a:r>
+              <a:rPr sz="1225" b="1">
+                <a:solidFill>
+                  <a:srgbClr val="0B1220"/>
+                </a:solidFill>
+                <a:latin typeface="Aptos"/>
+                <a:ea typeface="Aptos"/>
+                <a:cs typeface="Aptos"/>
+              </a:rPr>
+              <a:t>不要再寫舊式頂層 version: "3.8"</a:t>
+            </a:r>
+          </a:p>
+          <a:p>
+            <a:pPr algn="ctr">
+              <a:lnSpc>
+                <a:spcPct val="106000"/>
+              </a:lnSpc>
+              <a:buNone/>
+              <a:defRPr sz="1125" b="0">
+                <a:solidFill>
+                  <a:srgbClr val="334155"/>
+                </a:solidFill>
+                <a:latin typeface="Aptos"/>
+                <a:ea typeface="Aptos"/>
+                <a:cs typeface="Aptos"/>
+              </a:defRPr>
+            </a:pPr>
+            <a:r>
+              <a:rPr sz="1125" b="0">
+                <a:solidFill>
+                  <a:srgbClr val="334155"/>
+                </a:solidFill>
+                <a:latin typeface="Aptos"/>
+                <a:ea typeface="Aptos"/>
+                <a:cs typeface="Aptos"/>
+              </a:rPr>
+              <a:t>Docker Compose V2 會用 Compose Specification。</a:t>
+            </a:r>
+          </a:p>
+        </p:txBody>
+      </p:sp>
+      <p:sp>
+        <p:nvSpPr>
+          <p:cNvPr id="5" name=""/>
+          <p:cNvSpPr>
+            <a:spLocks noGrp="1"/>
+          </p:cNvSpPr>
+          <p:nvPr/>
+        </p:nvSpPr>
+        <p:spPr>
+          <a:xfrm>
+            <a:off x="4457700" y="1457325"/>
+            <a:ext cx="3238500" cy="2476500"/>
+          </a:xfrm>
+          <a:prstGeom prst="roundRect">
+            <a:avLst>
+              <a:gd name="adj" fmla="val 8000"/>
+            </a:avLst>
+          </a:prstGeom>
+          <a:solidFill>
+            <a:srgbClr val="EAF7EF"/>
+          </a:solidFill>
+          <a:ln w="9525">
+            <a:solidFill>
+              <a:srgbClr val="B7E4C7"/>
+            </a:solidFill>
+            <a:prstDash val="solid"/>
+          </a:ln>
+        </p:spPr>
+        <p:txBody>
+          <a:bodyPr lIns="209550" tIns="209550" rIns="209550" bIns="209550" anchor="t">
+            <a:normAutofit fontScale="100000"/>
+          </a:bodyPr>
+          <a:lstStyle/>
+          <a:p>
+            <a:pPr algn="ctr">
+              <a:lnSpc>
+                <a:spcPct val="106000"/>
+              </a:lnSpc>
+              <a:buNone/>
+              <a:defRPr sz="1700" b="1">
+                <a:solidFill>
+                  <a:srgbClr val="087F5B"/>
+                </a:solidFill>
+                <a:latin typeface="Aptos Display"/>
+                <a:ea typeface="Aptos Display"/>
+                <a:cs typeface="Aptos Display"/>
+              </a:defRPr>
+            </a:pPr>
+            <a:r>
+              <a:rPr sz="1700" b="1">
+                <a:solidFill>
+                  <a:srgbClr val="087F5B"/>
+                </a:solidFill>
+                <a:latin typeface="Aptos Display"/>
+                <a:ea typeface="Aptos Display"/>
+                <a:cs typeface="Aptos Display"/>
+              </a:rPr>
+              <a:t>Service image</a:t>
+            </a:r>
+          </a:p>
+          <a:p>
+            <a:pPr>
+              <a:buNone/>
+              <a:defRPr sz="500"/>
+            </a:pPr>
+          </a:p>
+          <a:p>
+            <a:pPr algn="ctr">
+              <a:lnSpc>
+                <a:spcPct val="106000"/>
+              </a:lnSpc>
+              <a:buNone/>
+              <a:defRPr sz="1225" b="1">
+                <a:solidFill>
+                  <a:srgbClr val="0B1220"/>
+                </a:solidFill>
+                <a:latin typeface="Aptos"/>
+                <a:ea typeface="Aptos"/>
+                <a:cs typeface="Aptos"/>
+              </a:defRPr>
+            </a:pPr>
+            <a:r>
+              <a:rPr sz="1225" b="1">
+                <a:solidFill>
+                  <a:srgbClr val="0B1220"/>
+                </a:solidFill>
+                <a:latin typeface="Aptos"/>
+                <a:ea typeface="Aptos"/>
+                <a:cs typeface="Aptos"/>
+              </a:rPr>
+              <a:t>要寫明確 tag</a:t>
+            </a:r>
+          </a:p>
+          <a:p>
+            <a:pPr algn="ctr">
+              <a:lnSpc>
+                <a:spcPct val="106000"/>
+              </a:lnSpc>
+              <a:buNone/>
+              <a:defRPr sz="1125" b="0">
+                <a:solidFill>
+                  <a:srgbClr val="334155"/>
+                </a:solidFill>
+                <a:latin typeface="Aptos Mono"/>
+                <a:ea typeface="Aptos Mono"/>
+                <a:cs typeface="Aptos Mono"/>
+              </a:defRPr>
+            </a:pPr>
+            <a:r>
+              <a:rPr sz="1125" b="0">
+                <a:solidFill>
+                  <a:srgbClr val="334155"/>
+                </a:solidFill>
+                <a:latin typeface="Aptos Mono"/>
+                <a:ea typeface="Aptos Mono"/>
+                <a:cs typeface="Aptos Mono"/>
+              </a:rPr>
+              <a:t>mysql:8.0</a:t>
+            </a:r>
+          </a:p>
+          <a:p>
+            <a:pPr algn="ctr">
+              <a:lnSpc>
+                <a:spcPct val="106000"/>
+              </a:lnSpc>
+              <a:buNone/>
+              <a:defRPr sz="1125" b="0">
+                <a:solidFill>
+                  <a:srgbClr val="334155"/>
+                </a:solidFill>
+                <a:latin typeface="Aptos Mono"/>
+                <a:ea typeface="Aptos Mono"/>
+                <a:cs typeface="Aptos Mono"/>
+              </a:defRPr>
+            </a:pPr>
+            <a:r>
+              <a:rPr sz="1125" b="0">
+                <a:solidFill>
+                  <a:srgbClr val="334155"/>
+                </a:solidFill>
+                <a:latin typeface="Aptos Mono"/>
+                <a:ea typeface="Aptos Mono"/>
+                <a:cs typeface="Aptos Mono"/>
+              </a:rPr>
+              <a:t>todo-backend:1.0.0</a:t>
+            </a:r>
+          </a:p>
+        </p:txBody>
+      </p:sp>
+      <p:sp>
+        <p:nvSpPr>
+          <p:cNvPr id="6" name=""/>
+          <p:cNvSpPr>
+            <a:spLocks noGrp="1"/>
+          </p:cNvSpPr>
+          <p:nvPr/>
+        </p:nvSpPr>
+        <p:spPr>
+          <a:xfrm>
+            <a:off x="8229600" y="1457325"/>
+            <a:ext cx="3238500" cy="2476500"/>
+          </a:xfrm>
+          <a:prstGeom prst="roundRect">
+            <a:avLst>
+              <a:gd name="adj" fmla="val 8000"/>
+            </a:avLst>
+          </a:prstGeom>
+          <a:solidFill>
+            <a:srgbClr val="FFF7E6"/>
+          </a:solidFill>
+          <a:ln w="9525">
+            <a:solidFill>
+              <a:srgbClr val="FFD999"/>
+            </a:solidFill>
+            <a:prstDash val="solid"/>
+          </a:ln>
+        </p:spPr>
+        <p:txBody>
+          <a:bodyPr lIns="209550" tIns="209550" rIns="209550" bIns="209550" anchor="t">
+            <a:normAutofit fontScale="100000"/>
+          </a:bodyPr>
+          <a:lstStyle/>
+          <a:p>
+            <a:pPr algn="ctr">
+              <a:lnSpc>
+                <a:spcPct val="106000"/>
+              </a:lnSpc>
+              <a:buNone/>
+              <a:defRPr sz="1700" b="1">
+                <a:solidFill>
+                  <a:srgbClr val="A16207"/>
+                </a:solidFill>
+                <a:latin typeface="Aptos Display"/>
+                <a:ea typeface="Aptos Display"/>
+                <a:cs typeface="Aptos Display"/>
+              </a:defRPr>
+            </a:pPr>
+            <a:r>
+              <a:rPr sz="1700" b="1">
+                <a:solidFill>
+                  <a:srgbClr val="A16207"/>
+                </a:solidFill>
+                <a:latin typeface="Aptos Display"/>
+                <a:ea typeface="Aptos Display"/>
+                <a:cs typeface="Aptos Display"/>
+              </a:rPr>
+              <a:t>Build 服務</a:t>
+            </a:r>
+          </a:p>
+          <a:p>
+            <a:pPr>
+              <a:buNone/>
+              <a:defRPr sz="500"/>
+            </a:pPr>
+          </a:p>
+          <a:p>
+            <a:pPr algn="ctr">
+              <a:lnSpc>
+                <a:spcPct val="106000"/>
+              </a:lnSpc>
+              <a:buNone/>
+              <a:defRPr sz="1225" b="1">
+                <a:solidFill>
+                  <a:srgbClr val="0B1220"/>
+                </a:solidFill>
+                <a:latin typeface="Aptos"/>
+                <a:ea typeface="Aptos"/>
+                <a:cs typeface="Aptos"/>
+              </a:defRPr>
+            </a:pPr>
+            <a:r>
+              <a:rPr sz="1225" b="1">
+                <a:solidFill>
+                  <a:srgbClr val="0B1220"/>
+                </a:solidFill>
+                <a:latin typeface="Aptos"/>
+                <a:ea typeface="Aptos"/>
+                <a:cs typeface="Aptos"/>
+              </a:rPr>
+              <a:t>image + build 可以同時寫</a:t>
+            </a:r>
+          </a:p>
+          <a:p>
+            <a:pPr algn="ctr">
+              <a:lnSpc>
+                <a:spcPct val="106000"/>
+              </a:lnSpc>
+              <a:buNone/>
+              <a:defRPr sz="1125" b="0">
+                <a:solidFill>
+                  <a:srgbClr val="334155"/>
+                </a:solidFill>
+                <a:latin typeface="Aptos"/>
+                <a:ea typeface="Aptos"/>
+                <a:cs typeface="Aptos"/>
+              </a:defRPr>
+            </a:pPr>
+            <a:r>
+              <a:rPr sz="1125" b="0">
+                <a:solidFill>
+                  <a:srgbClr val="334155"/>
+                </a:solidFill>
+                <a:latin typeface="Aptos"/>
+                <a:ea typeface="Aptos"/>
+                <a:cs typeface="Aptos"/>
+              </a:rPr>
+              <a:t>build 負責建立；image 負責命名與版本。</a:t>
+            </a:r>
+          </a:p>
+        </p:txBody>
+      </p:sp>
+      <p:sp>
+        <p:nvSpPr>
+          <p:cNvPr id="7" name=""/>
+          <p:cNvSpPr>
+            <a:spLocks noGrp="1"/>
+          </p:cNvSpPr>
+          <p:nvPr/>
+        </p:nvSpPr>
+        <p:spPr>
+          <a:xfrm>
+            <a:off x="1143000" y="4324350"/>
+            <a:ext cx="9144000" cy="628650"/>
+          </a:xfrm>
+          <a:prstGeom prst="roundRect">
+            <a:avLst>
+              <a:gd name="adj" fmla="val 8000"/>
+            </a:avLst>
+          </a:prstGeom>
+          <a:solidFill>
+            <a:srgbClr val="111827"/>
+          </a:solidFill>
+          <a:ln w="0">
+            <a:noFill/>
+            <a:prstDash val="solid"/>
+          </a:ln>
+        </p:spPr>
+        <p:txBody>
+          <a:bodyPr lIns="152400" tIns="152400" rIns="152400" bIns="152400" anchor="t">
+            <a:normAutofit fontScale="100000"/>
+          </a:bodyPr>
+          <a:lstStyle/>
+          <a:p>
+            <a:pPr algn="ctr">
+              <a:lnSpc>
+                <a:spcPct val="106000"/>
+              </a:lnSpc>
+              <a:buNone/>
+              <a:defRPr sz="1500" b="1">
+                <a:solidFill>
+                  <a:srgbClr val="FFFFFF"/>
+                </a:solidFill>
+                <a:latin typeface="Aptos"/>
+                <a:ea typeface="Aptos"/>
+                <a:cs typeface="Aptos"/>
+              </a:defRPr>
+            </a:pPr>
+            <a:r>
+              <a:rPr sz="1500" b="1">
+                <a:solidFill>
+                  <a:srgbClr val="FFFFFF"/>
+                </a:solidFill>
+                <a:latin typeface="Aptos"/>
+                <a:ea typeface="Aptos"/>
+                <a:cs typeface="Aptos"/>
+              </a:rPr>
+              <a:t>教學口訣：Compose 不寫舊 version；Image 不靠 latest。</a:t>
+            </a:r>
+          </a:p>
+        </p:txBody>
+      </p:sp>
+      <p:sp>
+        <p:nvSpPr>
+          <p:cNvPr id="8" name=""/>
+          <p:cNvSpPr>
+            <a:spLocks noGrp="1"/>
+          </p:cNvSpPr>
+          <p:nvPr/>
+        </p:nvSpPr>
+        <p:spPr>
+          <a:xfrm>
+            <a:off x="1714500" y="5156200"/>
+            <a:ext cx="8001000" cy="514350"/>
+          </a:xfrm>
+          <a:prstGeom prst="roundRect">
+            <a:avLst>
+              <a:gd name="adj" fmla="val 8000"/>
+            </a:avLst>
+          </a:prstGeom>
+          <a:solidFill>
+            <a:srgbClr val="EEF2F7"/>
+          </a:solidFill>
+          <a:ln w="9525">
+            <a:solidFill>
+              <a:srgbClr val="D9E2EC"/>
+            </a:solidFill>
+            <a:prstDash val="solid"/>
+          </a:ln>
+        </p:spPr>
+        <p:txBody>
+          <a:bodyPr lIns="152400" tIns="152400" rIns="152400" bIns="152400" anchor="t">
+            <a:normAutofit fontScale="100000"/>
+          </a:bodyPr>
+          <a:lstStyle/>
+          <a:p>
+            <a:pPr algn="ctr">
+              <a:lnSpc>
+                <a:spcPct val="106000"/>
+              </a:lnSpc>
+              <a:buNone/>
+              <a:defRPr sz="1175" b="1">
+                <a:solidFill>
+                  <a:srgbClr val="0B1220"/>
+                </a:solidFill>
+                <a:latin typeface="Aptos Mono"/>
+                <a:ea typeface="Aptos Mono"/>
+                <a:cs typeface="Aptos Mono"/>
+              </a:defRPr>
+            </a:pPr>
+            <a:r>
+              <a:rPr sz="1175" b="1">
+                <a:solidFill>
+                  <a:srgbClr val="0B1220"/>
+                </a:solidFill>
+                <a:latin typeface="Aptos Mono"/>
+                <a:ea typeface="Aptos Mono"/>
+                <a:cs typeface="Aptos Mono"/>
+              </a:rPr>
+              <a:t>services:  frontend:  image: todo-frontend:1.0.0  build: ./frontend</a:t>
+            </a:r>
+          </a:p>
+        </p:txBody>
+      </p:sp>
+      <p:sp>
+        <p:nvSpPr>
+          <p:cNvPr id="70" name=""/>
+          <p:cNvSpPr>
+            <a:spLocks noGrp="1"/>
+          </p:cNvSpPr>
+          <p:nvPr/>
+        </p:nvSpPr>
+        <p:spPr>
+          <a:xfrm>
+            <a:off x="685800" y="6305550"/>
+            <a:ext cx="9906000" cy="13335"/>
+          </a:xfrm>
+          <a:prstGeom prst="rect">
+            <a:avLst/>
+          </a:prstGeom>
+          <a:solidFill>
+            <a:srgbClr val="D9E2EC"/>
+          </a:solidFill>
+          <a:ln w="0">
+            <a:noFill/>
+            <a:prstDash val="solid"/>
+          </a:ln>
+        </p:spPr>
+        <p:txBody>
+          <a:bodyPr lIns="0" tIns="0" rIns="0" bIns="0" anchor="t">
+            <a:normAutofit fontScale="100000"/>
+          </a:bodyPr>
+          <a:lstStyle/>
+        </p:txBody>
+      </p:sp>
+      <p:sp>
+        <p:nvSpPr>
+          <p:cNvPr id="71" name=""/>
+          <p:cNvSpPr>
+            <a:spLocks noGrp="1"/>
+          </p:cNvSpPr>
+          <p:nvPr/>
+        </p:nvSpPr>
+        <p:spPr>
+          <a:xfrm>
+            <a:off x="685800" y="6400800"/>
+            <a:ext cx="2762250" cy="171450"/>
+          </a:xfrm>
+          <a:prstGeom prst="rect">
+            <a:avLst/>
+          </a:prstGeom>
+          <a:noFill/>
+          <a:ln w="0">
+            <a:noFill/>
+            <a:prstDash val="solid"/>
+          </a:ln>
+        </p:spPr>
+        <p:txBody>
+          <a:bodyPr lIns="0" tIns="0" rIns="0" bIns="0" anchor="t">
+            <a:normAutofit fontScale="100000"/>
+          </a:bodyPr>
+          <a:lstStyle/>
+          <a:p>
+            <a:pPr algn="l">
+              <a:lnSpc>
+                <a:spcPct val="106000"/>
+              </a:lnSpc>
+              <a:buNone/>
+              <a:defRPr sz="825" b="0">
+                <a:solidFill>
+                  <a:srgbClr val="64748B"/>
+                </a:solidFill>
+                <a:latin typeface="Aptos"/>
+                <a:ea typeface="Aptos"/>
+                <a:cs typeface="Aptos"/>
+              </a:defRPr>
+            </a:pPr>
+            <a:r>
+              <a:rPr sz="825" b="0">
+                <a:solidFill>
+                  <a:srgbClr val="64748B"/>
+                </a:solidFill>
+                <a:latin typeface="Aptos"/>
+                <a:ea typeface="Aptos"/>
+                <a:cs typeface="Aptos"/>
+              </a:rPr>
+              <a:t>Docker 基礎教學｜第 6 堂</a:t>
+            </a:r>
+          </a:p>
+        </p:txBody>
+      </p:sp>
+      <p:sp>
+        <p:nvSpPr>
+          <p:cNvPr id="72" name=""/>
+          <p:cNvSpPr>
+            <a:spLocks noGrp="1"/>
+          </p:cNvSpPr>
+          <p:nvPr/>
+        </p:nvSpPr>
+        <p:spPr>
+          <a:xfrm>
+            <a:off x="10858500" y="6381750"/>
+            <a:ext cx="723900" cy="190500"/>
+          </a:xfrm>
+          <a:prstGeom prst="rect">
+            <a:avLst/>
+          </a:prstGeom>
+          <a:noFill/>
+          <a:ln w="0">
+            <a:noFill/>
+            <a:prstDash val="solid"/>
+          </a:ln>
+        </p:spPr>
+        <p:txBody>
+          <a:bodyPr lIns="0" tIns="0" rIns="0" bIns="0" anchor="t">
+            <a:normAutofit fontScale="100000"/>
+          </a:bodyPr>
+          <a:lstStyle/>
+          <a:p>
+            <a:pPr algn="r">
+              <a:lnSpc>
+                <a:spcPct val="106000"/>
+              </a:lnSpc>
+              <a:buNone/>
+              <a:defRPr sz="900" b="1">
+                <a:solidFill>
+                  <a:srgbClr val="64748B"/>
+                </a:solidFill>
+                <a:latin typeface="Aptos"/>
+                <a:ea typeface="Aptos"/>
+                <a:cs typeface="Aptos"/>
+              </a:defRPr>
+            </a:pPr>
+            <a:r>
+              <a:rPr sz="900" b="1">
+                <a:solidFill>
+                  <a:srgbClr val="64748B"/>
+                </a:solidFill>
+                <a:latin typeface="Aptos"/>
+                <a:ea typeface="Aptos"/>
+                <a:cs typeface="Aptos"/>
+              </a:rPr>
+              <a:t>09B</a:t>
+            </a:r>
+          </a:p>
+        </p:txBody>
+      </p:sp>
+    </p:spTree>
+  </p:cSld>
+  <p:clrMapOvr>
+    <a:masterClrMapping/>
+  </p:clrMapOvr>
+</p:sld>
+</file>
+
 <file path=ppt/slides/slide2.xml><?xml version="1.0" encoding="utf-8"?>
 <p:sld xmlns:p="http://schemas.openxmlformats.org/presentationml/2006/main">
   <p:cSld>
@@ -13881,6 +14679,23 @@
                   <a:srgbClr val="F8FAFC"/>
                 </a:solidFill>
               </a:rPr>
+              <a:t>    image: todo-frontend:1.0.0</a:t>
+            </a:r>
+          </a:p>
+          <a:p xmlns:a="http://schemas.openxmlformats.org/drawingml/2006/main">
+            <a:pPr algn="l">
+              <a:defRPr sz="1275">
+                <a:solidFill>
+                  <a:srgbClr val="F8FAFC"/>
+                </a:solidFill>
+              </a:defRPr>
+            </a:pPr>
+            <a:r>
+              <a:rPr sz="1275">
+                <a:solidFill>
+                  <a:srgbClr val="F8FAFC"/>
+                </a:solidFill>
+              </a:rPr>
               <a:t>    build: ./frontend</a:t>
             </a:r>
           </a:p>
@@ -13938,6 +14753,23 @@
                 </a:solidFill>
               </a:rPr>
               <a:t>  backend:</a:t>
+            </a:r>
+          </a:p>
+          <a:p xmlns:a="http://schemas.openxmlformats.org/drawingml/2006/main">
+            <a:pPr algn="l">
+              <a:defRPr sz="1275">
+                <a:solidFill>
+                  <a:srgbClr val="F8FAFC"/>
+                </a:solidFill>
+              </a:defRPr>
+            </a:pPr>
+            <a:r>
+              <a:rPr sz="1275">
+                <a:solidFill>
+                  <a:srgbClr val="F8FAFC"/>
+                </a:solidFill>
+              </a:rPr>
+              <a:t>    image: todo-backend:1.0.0</a:t>
             </a:r>
           </a:p>
           <a:p xmlns:a="http://schemas.openxmlformats.org/drawingml/2006/main">

</xml_diff>